<commit_message>
Réunion de cadrage décalée au mardi 13 octobre
Co-Authored-By: Claude Fable 5.1 <noreply@anthropic.com>
Claude-Session: https://claude.ai/code/session_0179U1EgeN6zS3U2LunpEbFp
</commit_message>
<xml_diff>
--- a/docs/offre/cadrage/Reunion_de_cadrage_EGUITRA.pptx
+++ b/docs/offre/cadrage/Reunion_de_cadrage_EGUITRA.pptx
@@ -120,14 +120,14 @@
   <p:extLst>
     <p:ext uri="{521415D9-36F7-43E2-AB2F-B90AF26B5E84}">
       <p14:sectionLst xmlns:p14="http://schemas.microsoft.com/office/powerpoint/2010/main">
-        <p14:section name="Ouverture" id="{f8c3f552-3caf-610d-1763-2e3fed0c62ef}">
+        <p14:section name="Ouverture" id="{165dcf7e-2b0e-a3aa-64fd-5768a274d000}">
           <p14:sldIdLst>
             <p14:sldId id="256"/>
             <p14:sldId id="257"/>
             <p14:sldId id="258"/>
           </p14:sldIdLst>
         </p14:section>
-        <p14:section name="Le projet" id="{d3a0cab8-ac42-7017-0f65-8d1d5eca7a9c}">
+        <p14:section name="Le projet" id="{1f511a41-255c-7460-ca00-4e54409d5296}">
           <p14:sldIdLst>
             <p14:sldId id="259"/>
             <p14:sldId id="260"/>
@@ -135,7 +135,7 @@
             <p14:sldId id="262"/>
           </p14:sldIdLst>
         </p14:section>
-        <p14:section name="Ateliers" id="{bd5b9ea0-7861-b076-e68a-2c8d5d01d187}">
+        <p14:section name="Ateliers" id="{42552e83-e9eb-0389-953e-c1b88c49b383}">
           <p14:sldIdLst>
             <p14:sldId id="263"/>
             <p14:sldId id="264"/>
@@ -143,7 +143,7 @@
             <p14:sldId id="266"/>
           </p14:sldIdLst>
         </p14:section>
-        <p14:section name="Décisions" id="{321833bb-2a86-1393-0497-8db5d1e0f1c9}">
+        <p14:section name="Décisions" id="{9b2eec84-0d0d-80e3-e9aa-a2e20d17434d}">
           <p14:sldIdLst>
             <p14:sldId id="267"/>
             <p14:sldId id="268"/>
@@ -2505,7 +2505,7 @@
                   <a:schemeClr val="accent4"/>
                 </a:solidFill>
               </a:rPr>
-              <a:t>Lundi 12 octobre 2026, 10 h, locaux d'EGUITRA GROUP</a:t>
+              <a:t>Mardi 13 octobre 2026, 10 h, locaux d'EGUITRA GROUP</a:t>
             </a:r>
             <a:endParaRPr lang="en-US" sz="1800" dirty="0"/>
           </a:p>
@@ -9150,7 +9150,7 @@
                   <a:schemeClr val="tx1"/>
                 </a:solidFill>
               </a:rPr>
-              <a:t>Quatre semaines, du 12 octobre au 6 novembre</a:t>
+              <a:t>Quatre semaines, du 13 octobre au 6 novembre</a:t>
             </a:r>
             <a:endParaRPr lang="en-US" sz="2800" dirty="0"/>
           </a:p>
@@ -9227,7 +9227,7 @@
                   <a:srgbClr val="FFFFFF"/>
                 </a:solidFill>
               </a:rPr>
-              <a:t>12 au 16 oct.</a:t>
+              <a:t>13 au 16 oct.</a:t>
             </a:r>
             <a:endParaRPr lang="en-US" sz="1500" dirty="0"/>
           </a:p>

</xml_diff>

<commit_message>
Réunion de cadrage ramenée à deux heures, ordre du jour d'une page
Les ateliers transport, BTP et immobilier passent en séances de trente
minutes dans la semaine. Présentation, kit et mail alignés.

Co-Authored-By: Claude Fable 5.1 <noreply@anthropic.com>
Claude-Session: https://claude.ai/code/session_0179U1EgeN6zS3U2LunpEbFp
</commit_message>
<xml_diff>
--- a/docs/offre/cadrage/Reunion_de_cadrage_EGUITRA.pptx
+++ b/docs/offre/cadrage/Reunion_de_cadrage_EGUITRA.pptx
@@ -120,14 +120,14 @@
   <p:extLst>
     <p:ext uri="{521415D9-36F7-43E2-AB2F-B90AF26B5E84}">
       <p14:sectionLst xmlns:p14="http://schemas.microsoft.com/office/powerpoint/2010/main">
-        <p14:section name="Ouverture" id="{165dcf7e-2b0e-a3aa-64fd-5768a274d000}">
+        <p14:section name="Ouverture" id="{3d26929d-9e95-b500-9df2-00e99b48ee07}">
           <p14:sldIdLst>
             <p14:sldId id="256"/>
             <p14:sldId id="257"/>
             <p14:sldId id="258"/>
           </p14:sldIdLst>
         </p14:section>
-        <p14:section name="Le projet" id="{1f511a41-255c-7460-ca00-4e54409d5296}">
+        <p14:section name="Le projet" id="{0871fc15-348f-3bcc-4ab3-852963ec8b58}">
           <p14:sldIdLst>
             <p14:sldId id="259"/>
             <p14:sldId id="260"/>
@@ -135,7 +135,7 @@
             <p14:sldId id="262"/>
           </p14:sldIdLst>
         </p14:section>
-        <p14:section name="Ateliers" id="{42552e83-e9eb-0389-953e-c1b88c49b383}">
+        <p14:section name="Ateliers" id="{8916fd0f-db69-6e7c-5ebf-7eac4defccce}">
           <p14:sldIdLst>
             <p14:sldId id="263"/>
             <p14:sldId id="264"/>
@@ -143,7 +143,7 @@
             <p14:sldId id="266"/>
           </p14:sldIdLst>
         </p14:section>
-        <p14:section name="Décisions" id="{9b2eec84-0d0d-80e3-e9aa-a2e20d17434d}">
+        <p14:section name="Décisions" id="{4ee3f2f9-1a1f-f67f-6758-6dc4fd706119}">
           <p14:sldIdLst>
             <p14:sldId id="267"/>
             <p14:sldId id="268"/>
@@ -554,7 +554,7 @@
           <a:p>
             <a:r>
               <a:rPr lang="en-US" dirty="0"/>
-              <a:t>Accueil. Se présenter, présenter l'équipe, remercier pour l'accord de principe. Rappeler que la réunion dure une demi-journée et que l'on sort avec des décisions, pas avec des idées.</a:t>
+              <a:t>Accueil. Se présenter, présenter l'équipe, remercier pour l'accord de principe. Rappeler que la réunion dure deux heures et que l'on sort avec des décisions, pas avec des idées. Les ateliers métiers se tiennent dans la semaine, trente minutes chacun.</a:t>
             </a:r>
             <a:endParaRPr lang="en-US" dirty="0"/>
           </a:p>
@@ -1698,7 +1698,7 @@
           <a:p>
             <a:r>
               <a:rPr lang="en-US" dirty="0"/>
-              <a:t>Trois référents différents, quinze minutes chacun. Repartir avec les listes : flotte, chantiers, biens. Elles conditionnent la reprise des données.</a:t>
+              <a:t>Ces trois ateliers ne se tiennent pas aujourd'hui : trente minutes chacun avec le référent concerné, mercredi 14 ou jeudi 15, sur place ou à distance. Aujourd'hui on fixe les créneaux et on demande les listes.</a:t>
             </a:r>
             <a:endParaRPr lang="en-US" dirty="0"/>
           </a:p>
@@ -2505,7 +2505,7 @@
                   <a:schemeClr val="accent4"/>
                 </a:solidFill>
               </a:rPr>
-              <a:t>Mardi 13 octobre 2026, 10 h, locaux d'EGUITRA GROUP</a:t>
+              <a:t>Mardi 13 octobre 2026, de 10 h à 12 h, locaux d'EGUITRA GROUP</a:t>
             </a:r>
             <a:endParaRPr lang="en-US" sz="1800" dirty="0"/>
           </a:p>
@@ -2604,7 +2604,7 @@
                   <a:schemeClr val="tx1"/>
                 </a:solidFill>
               </a:rPr>
-              <a:t>Atelier AxisPro Suite, 30 minutes</a:t>
+              <a:t>AxisPro Suite, 15 minutes</a:t>
             </a:r>
             <a:endParaRPr lang="en-US" sz="2800" dirty="0"/>
           </a:p>
@@ -2945,7 +2945,7 @@
                   <a:schemeClr val="tx1"/>
                 </a:solidFill>
               </a:rPr>
-              <a:t>Technique, charte et accès, 20 minutes</a:t>
+              <a:t>Technique, charte et accès, 15 minutes</a:t>
             </a:r>
             <a:endParaRPr lang="en-US" sz="2800" dirty="0"/>
           </a:p>
@@ -3497,7 +3497,7 @@
                   <a:schemeClr val="tx1"/>
                 </a:solidFill>
               </a:rPr>
-              <a:t>Les décisions à prendre avant 14 h</a:t>
+              <a:t>Les décisions à prendre avant midi</a:t>
             </a:r>
             <a:endParaRPr lang="en-US" sz="2800" dirty="0"/>
           </a:p>
@@ -5938,7 +5938,7 @@
                   <a:schemeClr val="tx1"/>
                 </a:solidFill>
               </a:rPr>
-              <a:t>Ce que nous devons avoir décidé à 14 h</a:t>
+              <a:t>Ce que nous devons avoir décidé à midi</a:t>
             </a:r>
             <a:endParaRPr lang="en-US" sz="2800" dirty="0"/>
           </a:p>
@@ -6577,7 +6577,7 @@
                   <a:schemeClr val="tx1"/>
                 </a:solidFill>
               </a:rPr>
-              <a:t>Ordre du jour, une demi-journée</a:t>
+              <a:t>Ordre du jour, deux heures</a:t>
             </a:r>
             <a:endParaRPr lang="en-US" sz="2800" dirty="0"/>
           </a:p>
@@ -6610,7 +6610,7 @@
                 <a:gridCol w="5852160"/>
                 <a:gridCol w="1280160"/>
               </a:tblGrid>
-              <a:tr h="384048">
+              <a:tr h="365760">
                 <a:tc>
                   <a:txBody>
                     <a:bodyPr/>
@@ -6747,7 +6747,7 @@
                             <a:schemeClr val="tx2"/>
                           </a:solidFill>
                         </a:rPr>
-                        <a:t>15 min</a:t>
+                        <a:t>10 min</a:t>
                       </a:r>
                       <a:endParaRPr lang="en-US" sz="1200" dirty="0"/>
                     </a:p>
@@ -6795,7 +6795,7 @@
                   </a:tcPr>
                 </a:tc>
               </a:tr>
-              <a:tr h="384048">
+              <a:tr h="365760">
                 <a:tc>
                   <a:txBody>
                     <a:bodyPr/>
@@ -6810,7 +6810,7 @@
                             <a:schemeClr val="accent1"/>
                           </a:solidFill>
                         </a:rPr>
-                        <a:t>10 h 15</a:t>
+                        <a:t>10 h 10</a:t>
                       </a:r>
                       <a:endParaRPr lang="en-US" sz="1300" dirty="0"/>
                     </a:p>
@@ -6932,7 +6932,7 @@
                             <a:schemeClr val="tx2"/>
                           </a:solidFill>
                         </a:rPr>
-                        <a:t>30 min</a:t>
+                        <a:t>20 min</a:t>
                       </a:r>
                       <a:endParaRPr lang="en-US" sz="1200" dirty="0"/>
                     </a:p>
@@ -6980,7 +6980,7 @@
                   </a:tcPr>
                 </a:tc>
               </a:tr>
-              <a:tr h="384048">
+              <a:tr h="365760">
                 <a:tc>
                   <a:txBody>
                     <a:bodyPr/>
@@ -6995,7 +6995,7 @@
                             <a:schemeClr val="accent1"/>
                           </a:solidFill>
                         </a:rPr>
-                        <a:t>10 h 45</a:t>
+                        <a:t>10 h 30</a:t>
                       </a:r>
                       <a:endParaRPr lang="en-US" sz="1300" dirty="0"/>
                     </a:p>
@@ -7056,7 +7056,7 @@
                             <a:schemeClr val="tx1"/>
                           </a:solidFill>
                         </a:rPr>
-                        <a:t>Atelier Finance</a:t>
+                        <a:t>Finance : plan de comptes, axes, approbations, seuils, clôture, états</a:t>
                       </a:r>
                       <a:endParaRPr lang="en-US" sz="1300" dirty="0"/>
                     </a:p>
@@ -7117,7 +7117,7 @@
                             <a:schemeClr val="tx2"/>
                           </a:solidFill>
                         </a:rPr>
-                        <a:t>60 min</a:t>
+                        <a:t>35 min</a:t>
                       </a:r>
                       <a:endParaRPr lang="en-US" sz="1200" dirty="0"/>
                     </a:p>
@@ -7165,7 +7165,7 @@
                   </a:tcPr>
                 </a:tc>
               </a:tr>
-              <a:tr h="384048">
+              <a:tr h="365760">
                 <a:tc>
                   <a:txBody>
                     <a:bodyPr/>
@@ -7180,7 +7180,7 @@
                             <a:schemeClr val="accent1"/>
                           </a:solidFill>
                         </a:rPr>
-                        <a:t>11 h 45</a:t>
+                        <a:t>11 h 05</a:t>
                       </a:r>
                       <a:endParaRPr lang="en-US" sz="1300" dirty="0"/>
                     </a:p>
@@ -7241,7 +7241,7 @@
                             <a:schemeClr val="tx1"/>
                           </a:solidFill>
                         </a:rPr>
-                        <a:t>Pause</a:t>
+                        <a:t>AxisPro Suite : grille, gates, data room, portail</a:t>
                       </a:r>
                       <a:endParaRPr lang="en-US" sz="1300" dirty="0"/>
                     </a:p>
@@ -7350,7 +7350,7 @@
                   </a:tcPr>
                 </a:tc>
               </a:tr>
-              <a:tr h="384048">
+              <a:tr h="365760">
                 <a:tc>
                   <a:txBody>
                     <a:bodyPr/>
@@ -7365,7 +7365,7 @@
                             <a:schemeClr val="accent1"/>
                           </a:solidFill>
                         </a:rPr>
-                        <a:t>12 h 00</a:t>
+                        <a:t>11 h 20</a:t>
                       </a:r>
                       <a:endParaRPr lang="en-US" sz="1300" dirty="0"/>
                     </a:p>
@@ -7426,7 +7426,7 @@
                             <a:schemeClr val="tx1"/>
                           </a:solidFill>
                         </a:rPr>
-                        <a:t>Ateliers Transport, BTP, Immobilier</a:t>
+                        <a:t>Technique et charte : domaine, logos, utilisateurs, relevés</a:t>
                       </a:r>
                       <a:endParaRPr lang="en-US" sz="1300" dirty="0"/>
                     </a:p>
@@ -7487,7 +7487,7 @@
                             <a:schemeClr val="tx2"/>
                           </a:solidFill>
                         </a:rPr>
-                        <a:t>45 min</a:t>
+                        <a:t>15 min</a:t>
                       </a:r>
                       <a:endParaRPr lang="en-US" sz="1200" dirty="0"/>
                     </a:p>
@@ -7535,7 +7535,7 @@
                   </a:tcPr>
                 </a:tc>
               </a:tr>
-              <a:tr h="384048">
+              <a:tr h="365760">
                 <a:tc>
                   <a:txBody>
                     <a:bodyPr/>
@@ -7550,7 +7550,7 @@
                             <a:schemeClr val="accent1"/>
                           </a:solidFill>
                         </a:rPr>
-                        <a:t>12 h 45</a:t>
+                        <a:t>11 h 35</a:t>
                       </a:r>
                       <a:endParaRPr lang="en-US" sz="1300" dirty="0"/>
                     </a:p>
@@ -7611,192 +7611,7 @@
                             <a:schemeClr val="tx1"/>
                           </a:solidFill>
                         </a:rPr>
-                        <a:t>Atelier AxisPro Suite</a:t>
-                      </a:r>
-                      <a:endParaRPr lang="en-US" sz="1300" dirty="0"/>
-                    </a:p>
-                  </a:txBody>
-                  <a:tcPr marL="54864" marR="54864" marT="54864" marB="54864">
-                    <a:lnL w="12700" cap="flat" cmpd="sng" algn="ctr">
-                      <a:solidFill>
-                        <a:srgbClr val="EEF3F6"/>
-                      </a:solidFill>
-                      <a:prstDash val="solid"/>
-                      <a:round/>
-                      <a:headEnd type="none" w="med" len="med"/>
-                      <a:tailEnd type="none" w="med" len="med"/>
-                    </a:lnL>
-                    <a:lnR w="12700" cap="flat" cmpd="sng" algn="ctr">
-                      <a:solidFill>
-                        <a:srgbClr val="EEF3F6"/>
-                      </a:solidFill>
-                      <a:prstDash val="solid"/>
-                      <a:round/>
-                      <a:headEnd type="none" w="med" len="med"/>
-                      <a:tailEnd type="none" w="med" len="med"/>
-                    </a:lnR>
-                    <a:lnT w="12700" cap="flat" cmpd="sng" algn="ctr">
-                      <a:solidFill>
-                        <a:srgbClr val="EEF3F6"/>
-                      </a:solidFill>
-                      <a:prstDash val="solid"/>
-                      <a:round/>
-                      <a:headEnd type="none" w="med" len="med"/>
-                      <a:tailEnd type="none" w="med" len="med"/>
-                    </a:lnT>
-                    <a:lnB w="12700" cap="flat" cmpd="sng" algn="ctr">
-                      <a:solidFill>
-                        <a:srgbClr val="EEF3F6"/>
-                      </a:solidFill>
-                      <a:prstDash val="solid"/>
-                      <a:round/>
-                      <a:headEnd type="none" w="med" len="med"/>
-                      <a:tailEnd type="none" w="med" len="med"/>
-                    </a:lnB>
-                    <a:solidFill>
-                      <a:srgbClr val="FFFFFF"/>
-                    </a:solidFill>
-                  </a:tcPr>
-                </a:tc>
-                <a:tc>
-                  <a:txBody>
-                    <a:bodyPr/>
-                    <a:lstStyle/>
-                    <a:p>
-                      <a:pPr algn="r" indent="0" marL="0">
-                        <a:buNone/>
-                      </a:pPr>
-                      <a:r>
-                        <a:rPr lang="en-US" sz="1200" dirty="0">
-                          <a:solidFill>
-                            <a:schemeClr val="tx2"/>
-                          </a:solidFill>
-                        </a:rPr>
-                        <a:t>30 min</a:t>
-                      </a:r>
-                      <a:endParaRPr lang="en-US" sz="1200" dirty="0"/>
-                    </a:p>
-                  </a:txBody>
-                  <a:tcPr marL="54864" marR="54864" marT="54864" marB="54864">
-                    <a:lnL w="12700" cap="flat" cmpd="sng" algn="ctr">
-                      <a:solidFill>
-                        <a:srgbClr val="EEF3F6"/>
-                      </a:solidFill>
-                      <a:prstDash val="solid"/>
-                      <a:round/>
-                      <a:headEnd type="none" w="med" len="med"/>
-                      <a:tailEnd type="none" w="med" len="med"/>
-                    </a:lnL>
-                    <a:lnR w="12700" cap="flat" cmpd="sng" algn="ctr">
-                      <a:solidFill>
-                        <a:srgbClr val="EEF3F6"/>
-                      </a:solidFill>
-                      <a:prstDash val="solid"/>
-                      <a:round/>
-                      <a:headEnd type="none" w="med" len="med"/>
-                      <a:tailEnd type="none" w="med" len="med"/>
-                    </a:lnR>
-                    <a:lnT w="12700" cap="flat" cmpd="sng" algn="ctr">
-                      <a:solidFill>
-                        <a:srgbClr val="EEF3F6"/>
-                      </a:solidFill>
-                      <a:prstDash val="solid"/>
-                      <a:round/>
-                      <a:headEnd type="none" w="med" len="med"/>
-                      <a:tailEnd type="none" w="med" len="med"/>
-                    </a:lnT>
-                    <a:lnB w="12700" cap="flat" cmpd="sng" algn="ctr">
-                      <a:solidFill>
-                        <a:srgbClr val="EEF3F6"/>
-                      </a:solidFill>
-                      <a:prstDash val="solid"/>
-                      <a:round/>
-                      <a:headEnd type="none" w="med" len="med"/>
-                      <a:tailEnd type="none" w="med" len="med"/>
-                    </a:lnB>
-                    <a:solidFill>
-                      <a:srgbClr val="FFFFFF"/>
-                    </a:solidFill>
-                  </a:tcPr>
-                </a:tc>
-              </a:tr>
-              <a:tr h="384048">
-                <a:tc>
-                  <a:txBody>
-                    <a:bodyPr/>
-                    <a:lstStyle/>
-                    <a:p>
-                      <a:pPr algn="l" indent="0" marL="0">
-                        <a:buNone/>
-                      </a:pPr>
-                      <a:r>
-                        <a:rPr lang="en-US" sz="1300" b="1" dirty="0">
-                          <a:solidFill>
-                            <a:schemeClr val="accent1"/>
-                          </a:solidFill>
-                        </a:rPr>
-                        <a:t>13 h 15</a:t>
-                      </a:r>
-                      <a:endParaRPr lang="en-US" sz="1300" dirty="0"/>
-                    </a:p>
-                  </a:txBody>
-                  <a:tcPr marL="54864" marR="54864" marT="54864" marB="54864">
-                    <a:lnL w="12700" cap="flat" cmpd="sng" algn="ctr">
-                      <a:solidFill>
-                        <a:srgbClr val="EEF3F6"/>
-                      </a:solidFill>
-                      <a:prstDash val="solid"/>
-                      <a:round/>
-                      <a:headEnd type="none" w="med" len="med"/>
-                      <a:tailEnd type="none" w="med" len="med"/>
-                    </a:lnL>
-                    <a:lnR w="12700" cap="flat" cmpd="sng" algn="ctr">
-                      <a:solidFill>
-                        <a:srgbClr val="EEF3F6"/>
-                      </a:solidFill>
-                      <a:prstDash val="solid"/>
-                      <a:round/>
-                      <a:headEnd type="none" w="med" len="med"/>
-                      <a:tailEnd type="none" w="med" len="med"/>
-                    </a:lnR>
-                    <a:lnT w="12700" cap="flat" cmpd="sng" algn="ctr">
-                      <a:solidFill>
-                        <a:srgbClr val="EEF3F6"/>
-                      </a:solidFill>
-                      <a:prstDash val="solid"/>
-                      <a:round/>
-                      <a:headEnd type="none" w="med" len="med"/>
-                      <a:tailEnd type="none" w="med" len="med"/>
-                    </a:lnT>
-                    <a:lnB w="12700" cap="flat" cmpd="sng" algn="ctr">
-                      <a:solidFill>
-                        <a:srgbClr val="EEF3F6"/>
-                      </a:solidFill>
-                      <a:prstDash val="solid"/>
-                      <a:round/>
-                      <a:headEnd type="none" w="med" len="med"/>
-                      <a:tailEnd type="none" w="med" len="med"/>
-                    </a:lnB>
-                    <a:solidFill>
-                      <a:srgbClr val="FFFFFF"/>
-                    </a:solidFill>
-                  </a:tcPr>
-                </a:tc>
-                <a:tc>
-                  <a:txBody>
-                    <a:bodyPr/>
-                    <a:lstStyle/>
-                    <a:p>
-                      <a:pPr indent="0" marL="0">
-                        <a:buNone/>
-                      </a:pPr>
-                      <a:r>
-                        <a:rPr lang="en-US" sz="1300" dirty="0">
-                          <a:solidFill>
-                            <a:schemeClr val="tx1"/>
-                          </a:solidFill>
-                        </a:rPr>
-                        <a:t>Technique, charte graphique, accès</a:t>
+                        <a:t>Décisions, référents, éléments à remettre, prochaines étapes</a:t>
                       </a:r>
                       <a:endParaRPr lang="en-US" sz="1300" dirty="0"/>
                     </a:p>
@@ -7905,7 +7720,7 @@
                   </a:tcPr>
                 </a:tc>
               </a:tr>
-              <a:tr h="384048">
+              <a:tr h="365760">
                 <a:tc>
                   <a:txBody>
                     <a:bodyPr/>
@@ -7920,7 +7735,7 @@
                             <a:schemeClr val="accent1"/>
                           </a:solidFill>
                         </a:rPr>
-                        <a:t>13 h 35</a:t>
+                        <a:t>11 h 55</a:t>
                       </a:r>
                       <a:endParaRPr lang="en-US" sz="1300" dirty="0"/>
                     </a:p>
@@ -7981,7 +7796,7 @@
                             <a:schemeClr val="tx1"/>
                           </a:solidFill>
                         </a:rPr>
-                        <a:t>Décisions, référents, prochaines étapes</a:t>
+                        <a:t>Clôture</a:t>
                       </a:r>
                       <a:endParaRPr lang="en-US" sz="1300" dirty="0"/>
                     </a:p>
@@ -8042,7 +7857,7 @@
                             <a:schemeClr val="tx2"/>
                           </a:solidFill>
                         </a:rPr>
-                        <a:t>25 min</a:t>
+                        <a:t>5 min</a:t>
                       </a:r>
                       <a:endParaRPr lang="en-US" sz="1200" dirty="0"/>
                     </a:p>
@@ -8094,6 +7909,66 @@
           </a:graphicData>
         </a:graphic>
       </p:graphicFrame>
+      <p:pic>
+        <p:nvPicPr>
+          <p:cNvPr id="4" name="Image 0" descr="preencoded.png">    </p:cNvPr>
+          <p:cNvPicPr>
+            <a:picLocks noChangeAspect="1"/>
+          </p:cNvPicPr>
+          <p:nvPr/>
+        </p:nvPicPr>
+        <p:blipFill>
+          <a:blip r:embed="rId1"/>
+          <a:stretch>
+            <a:fillRect/>
+          </a:stretch>
+        </p:blipFill>
+        <p:spPr>
+          <a:xfrm>
+            <a:off x="457200" y="3931920"/>
+            <a:ext cx="320040" cy="320040"/>
+          </a:xfrm>
+          <a:prstGeom prst="rect">
+            <a:avLst/>
+          </a:prstGeom>
+        </p:spPr>
+      </p:pic>
+      <p:sp>
+        <p:nvSpPr>
+          <p:cNvPr id="5" name="Text 1"/>
+          <p:cNvSpPr txBox="1"/>
+          <p:nvPr/>
+        </p:nvSpPr>
+        <p:spPr>
+          <a:xfrm>
+            <a:off x="914400" y="3840480"/>
+            <a:ext cx="7772400" cy="502920"/>
+          </a:xfrm>
+          <a:prstGeom prst="rect">
+            <a:avLst/>
+          </a:prstGeom>
+          <a:noFill/>
+          <a:ln/>
+        </p:spPr>
+        <p:txBody>
+          <a:bodyPr wrap="square" lIns="0" tIns="0" rIns="0" bIns="0" rtlCol="0" anchor="ctr"/>
+          <a:lstStyle/>
+          <a:p>
+            <a:pPr indent="0" marL="0">
+              <a:buNone/>
+            </a:pPr>
+            <a:r>
+              <a:rPr lang="en-US" sz="1250" dirty="0">
+                <a:solidFill>
+                  <a:schemeClr val="tx2"/>
+                </a:solidFill>
+              </a:rPr>
+              <a:t>Ateliers métiers transport, BTP et immobilier : 30 minutes chacun avec le référent concerné, mercredi 14 ou jeudi 15 octobre, sur place ou à distance.</a:t>
+            </a:r>
+            <a:endParaRPr lang="en-US" sz="1250" dirty="0"/>
+          </a:p>
+        </p:txBody>
+      </p:sp>
       <p:sp>
         <p:nvSpPr>
           <p:cNvPr id="25" name="Slide Number Placeholder 0"/>
@@ -10600,7 +10475,7 @@
                   <a:schemeClr val="tx1"/>
                 </a:solidFill>
               </a:rPr>
-              <a:t>Atelier Finance, 60 minutes</a:t>
+              <a:t>Finance, 35 minutes</a:t>
             </a:r>
             <a:endParaRPr lang="en-US" sz="2800" dirty="0"/>
           </a:p>
@@ -10959,7 +10834,7 @@
                   <a:schemeClr val="tx1"/>
                 </a:solidFill>
               </a:rPr>
-              <a:t>Ateliers métiers, 45 minutes</a:t>
+              <a:t>Ateliers métiers, 30 minutes chacun</a:t>
             </a:r>
             <a:endParaRPr lang="en-US" sz="2800" dirty="0"/>
           </a:p>

</xml_diff>